<commit_message>
Add files for final project
</commit_message>
<xml_diff>
--- a/Project-Presentation-Template.pptx
+++ b/Project-Presentation-Template.pptx
@@ -113,7 +113,41 @@
       </a:defRPr>
     </a:lvl9pPr>
   </p:defaultTextStyle>
+  <p:extLst>
+    <p:ext uri="{EFAFB233-063F-42B5-8137-9DF3F51BA10A}">
+      <p15:sldGuideLst xmlns:p15="http://schemas.microsoft.com/office/powerpoint/2012/main"/>
+    </p:ext>
+  </p:extLst>
 </p:presentation>
+</file>
+
+<file path=ppt/changesInfos/changesInfo1.xml><?xml version="1.0" encoding="utf-8"?>
+<pc:chgInfo xmlns:a="http://schemas.openxmlformats.org/drawingml/2006/main" xmlns:r="http://schemas.openxmlformats.org/officeDocument/2006/relationships" xmlns:ac="http://schemas.microsoft.com/office/drawing/2013/main/command" xmlns:pc="http://schemas.microsoft.com/office/powerpoint/2013/main/command">
+  <pc:docChgLst>
+    <pc:chgData name="Nguyen,Quang" userId="23891ed8-be2c-452b-90d3-fcb364b9bbff" providerId="ADAL" clId="{34BD0BAB-0731-4425-A030-A15B82932F5E}"/>
+    <pc:docChg chg="modSld">
+      <pc:chgData name="Nguyen,Quang" userId="23891ed8-be2c-452b-90d3-fcb364b9bbff" providerId="ADAL" clId="{34BD0BAB-0731-4425-A030-A15B82932F5E}" dt="2026-05-14T03:40:42.088" v="3" actId="20577"/>
+      <pc:docMkLst>
+        <pc:docMk/>
+      </pc:docMkLst>
+      <pc:sldChg chg="modSp mod">
+        <pc:chgData name="Nguyen,Quang" userId="23891ed8-be2c-452b-90d3-fcb364b9bbff" providerId="ADAL" clId="{34BD0BAB-0731-4425-A030-A15B82932F5E}" dt="2026-05-14T03:40:42.088" v="3" actId="20577"/>
+        <pc:sldMkLst>
+          <pc:docMk/>
+          <pc:sldMk cId="831070309" sldId="256"/>
+        </pc:sldMkLst>
+        <pc:spChg chg="mod">
+          <ac:chgData name="Nguyen,Quang" userId="23891ed8-be2c-452b-90d3-fcb364b9bbff" providerId="ADAL" clId="{34BD0BAB-0731-4425-A030-A15B82932F5E}" dt="2026-05-14T03:40:42.088" v="3" actId="20577"/>
+          <ac:spMkLst>
+            <pc:docMk/>
+            <pc:sldMk cId="831070309" sldId="256"/>
+            <ac:spMk id="2" creationId="{D709020E-F455-E944-BBDA-1052D6751E5E}"/>
+          </ac:spMkLst>
+        </pc:spChg>
+      </pc:sldChg>
+    </pc:docChg>
+  </pc:docChgLst>
+</pc:chgInfo>
 </file>
 
 <file path=ppt/slideLayouts/slideLayout1.xml><?xml version="1.0" encoding="utf-8"?>
@@ -263,7 +297,7 @@
           <a:p>
             <a:fld id="{3C5E3940-567D-0E4A-B27A-538E5CA3F251}" type="datetimeFigureOut">
               <a:rPr lang="en-US" smtClean="0"/>
-              <a:t>11/27/20</a:t>
+              <a:t>05/13/2026</a:t>
             </a:fld>
             <a:endParaRPr lang="en-US"/>
           </a:p>
@@ -461,7 +495,7 @@
           <a:p>
             <a:fld id="{3C5E3940-567D-0E4A-B27A-538E5CA3F251}" type="datetimeFigureOut">
               <a:rPr lang="en-US" smtClean="0"/>
-              <a:t>11/27/20</a:t>
+              <a:t>05/13/2026</a:t>
             </a:fld>
             <a:endParaRPr lang="en-US"/>
           </a:p>
@@ -669,7 +703,7 @@
           <a:p>
             <a:fld id="{3C5E3940-567D-0E4A-B27A-538E5CA3F251}" type="datetimeFigureOut">
               <a:rPr lang="en-US" smtClean="0"/>
-              <a:t>11/27/20</a:t>
+              <a:t>05/13/2026</a:t>
             </a:fld>
             <a:endParaRPr lang="en-US"/>
           </a:p>
@@ -867,7 +901,7 @@
           <a:p>
             <a:fld id="{3C5E3940-567D-0E4A-B27A-538E5CA3F251}" type="datetimeFigureOut">
               <a:rPr lang="en-US" smtClean="0"/>
-              <a:t>11/27/20</a:t>
+              <a:t>05/13/2026</a:t>
             </a:fld>
             <a:endParaRPr lang="en-US"/>
           </a:p>
@@ -1142,7 +1176,7 @@
           <a:p>
             <a:fld id="{3C5E3940-567D-0E4A-B27A-538E5CA3F251}" type="datetimeFigureOut">
               <a:rPr lang="en-US" smtClean="0"/>
-              <a:t>11/27/20</a:t>
+              <a:t>05/13/2026</a:t>
             </a:fld>
             <a:endParaRPr lang="en-US"/>
           </a:p>
@@ -1407,7 +1441,7 @@
           <a:p>
             <a:fld id="{3C5E3940-567D-0E4A-B27A-538E5CA3F251}" type="datetimeFigureOut">
               <a:rPr lang="en-US" smtClean="0"/>
-              <a:t>11/27/20</a:t>
+              <a:t>05/13/2026</a:t>
             </a:fld>
             <a:endParaRPr lang="en-US"/>
           </a:p>
@@ -1819,7 +1853,7 @@
           <a:p>
             <a:fld id="{3C5E3940-567D-0E4A-B27A-538E5CA3F251}" type="datetimeFigureOut">
               <a:rPr lang="en-US" smtClean="0"/>
-              <a:t>11/27/20</a:t>
+              <a:t>05/13/2026</a:t>
             </a:fld>
             <a:endParaRPr lang="en-US"/>
           </a:p>
@@ -1960,7 +1994,7 @@
           <a:p>
             <a:fld id="{3C5E3940-567D-0E4A-B27A-538E5CA3F251}" type="datetimeFigureOut">
               <a:rPr lang="en-US" smtClean="0"/>
-              <a:t>11/27/20</a:t>
+              <a:t>05/13/2026</a:t>
             </a:fld>
             <a:endParaRPr lang="en-US"/>
           </a:p>
@@ -2073,7 +2107,7 @@
           <a:p>
             <a:fld id="{3C5E3940-567D-0E4A-B27A-538E5CA3F251}" type="datetimeFigureOut">
               <a:rPr lang="en-US" smtClean="0"/>
-              <a:t>11/27/20</a:t>
+              <a:t>05/13/2026</a:t>
             </a:fld>
             <a:endParaRPr lang="en-US"/>
           </a:p>
@@ -2384,7 +2418,7 @@
           <a:p>
             <a:fld id="{3C5E3940-567D-0E4A-B27A-538E5CA3F251}" type="datetimeFigureOut">
               <a:rPr lang="en-US" smtClean="0"/>
-              <a:t>11/27/20</a:t>
+              <a:t>05/13/2026</a:t>
             </a:fld>
             <a:endParaRPr lang="en-US"/>
           </a:p>
@@ -2672,7 +2706,7 @@
           <a:p>
             <a:fld id="{3C5E3940-567D-0E4A-B27A-538E5CA3F251}" type="datetimeFigureOut">
               <a:rPr lang="en-US" smtClean="0"/>
-              <a:t>11/27/20</a:t>
+              <a:t>05/13/2026</a:t>
             </a:fld>
             <a:endParaRPr lang="en-US"/>
           </a:p>
@@ -2913,7 +2947,7 @@
           <a:p>
             <a:fld id="{3C5E3940-567D-0E4A-B27A-538E5CA3F251}" type="datetimeFigureOut">
               <a:rPr lang="en-US" smtClean="0"/>
-              <a:t>11/27/20</a:t>
+              <a:t>05/13/2026</a:t>
             </a:fld>
             <a:endParaRPr lang="en-US"/>
           </a:p>
@@ -3352,9 +3386,10 @@
           <a:lstStyle/>
           <a:p>
             <a:r>
-              <a:rPr lang="en-US" dirty="0"/>
-              <a:t>Project Title</a:t>
-            </a:r>
+              <a:rPr lang="en-US"/>
+              <a:t>Test</a:t>
+            </a:r>
+            <a:endParaRPr lang="en-US" dirty="0"/>
           </a:p>
         </p:txBody>
       </p:sp>

</xml_diff>